<commit_message>
docs: update README, pitch deck generator, and slide decks with complete revenue model and SKR buyback & burn flywheel
</commit_message>
<xml_diff>
--- a/docs/ClockLend_Pitch_Deck.pptx
+++ b/docs/ClockLend_Pitch_Deck.pptx
@@ -16,6 +16,7 @@
     <p:sldId id="264" r:id="rId16"/>
     <p:sldId id="265" r:id="rId17"/>
     <p:sldId id="266" r:id="rId18"/>
+    <p:sldId id="267" r:id="rId19"/>
   </p:sldIdLst>
   <p:sldSz cx="12191695" cy="6858000" type="screen4x3"/>
   <p:notesSz cx="6858000" cy="9144000"/>
@@ -612,22 +613,22 @@
           </a:p>
           <a:p>
             <a:r>
-              <a:t>"The ask is specific: a grand prize and the SKR integration prize. What you get in return is equally specific: a published Seeker app, seeded mainnet desks, and a borrower community — the lending layer for the social graph Solana Mobile is building."</a:t>
-            </a:r>
-          </a:p>
-          <a:p>
-            <a:r>
-              <a:t>Key Closing Points:</a:t>
-            </a:r>
-          </a:p>
-          <a:p>
-            <a:r>
-              <a:t>- Ready to ship on day one of Seeker retail deliveries.</a:t>
-            </a:r>
-          </a:p>
-          <a:p>
-            <a:r>
-              <a:t>- Full mainnet deployment already verified.</a:t>
+              <a:t>"The ecosystem case: ClockLend turns SKR from a holding into a working asset — staked for discounts, locked as collateral, priced by Pyth. And it gives every Seeker wallet a portable credit history — the missing primitive for the social graph Solana Mobile is building."</a:t>
+            </a:r>
+          </a:p>
+          <a:p>
+            <a:r>
+              <a:t>Key Ecosystem Takeaway:</a:t>
+            </a:r>
+          </a:p>
+          <a:p>
+            <a:r>
+              <a:t>- Seeker needs real utility dApps that can't exist on Apple/Google App Stores.</a:t>
+            </a:r>
+          </a:p>
+          <a:p>
+            <a:r>
+              <a:t>- ClockLend leverages Seed Vault, MWA, and NFC hardware features.</a:t>
             </a:r>
           </a:p>
         </p:txBody>
@@ -702,6 +703,96 @@
           </a:p>
           <a:p>
             <a:r>
+              <a:t>"The ask is specific: a grand prize and the SKR integration prize. What you get in return is equally specific: a published Seeker app, seeded mainnet desks, and a borrower community — the lending layer for the social graph Solana Mobile is building."</a:t>
+            </a:r>
+          </a:p>
+          <a:p>
+            <a:r>
+              <a:t>Key Closing Points:</a:t>
+            </a:r>
+          </a:p>
+          <a:p>
+            <a:r>
+              <a:t>- Ready to ship on day one of Seeker retail deliveries.</a:t>
+            </a:r>
+          </a:p>
+          <a:p>
+            <a:r>
+              <a:t>- Full mainnet deployment already verified.</a:t>
+            </a:r>
+          </a:p>
+        </p:txBody>
+      </p:sp>
+      <p:sp>
+        <p:nvSpPr>
+          <p:cNvPr id="4" name="Slide Number Placeholder 3"/>
+          <p:cNvSpPr>
+            <a:spLocks noGrp="1"/>
+          </p:cNvSpPr>
+          <p:nvPr>
+            <p:ph type="sldNum" idx="5" sz="quarter"/>
+          </p:nvPr>
+        </p:nvSpPr>
+        <p:spPr/>
+      </p:sp>
+    </p:spTree>
+  </p:cSld>
+  <p:clrMapOvr>
+    <a:masterClrMapping/>
+  </p:clrMapOvr>
+</p:notes>
+</file>
+
+<file path=ppt/notesSlides/notesSlide12.xml><?xml version="1.0" encoding="utf-8"?>
+<p:notes xmlns:a="http://schemas.openxmlformats.org/drawingml/2006/main" xmlns:p="http://schemas.openxmlformats.org/presentationml/2006/main" xmlns:r="http://schemas.openxmlformats.org/officeDocument/2006/relationships">
+  <p:cSld>
+    <p:spTree>
+      <p:nvGrpSpPr>
+        <p:cNvPr id="1" name=""/>
+        <p:cNvGrpSpPr/>
+        <p:nvPr/>
+      </p:nvGrpSpPr>
+      <p:grpSpPr>
+        <a:xfrm>
+          <a:off x="0" y="0"/>
+          <a:ext cx="0" cy="0"/>
+          <a:chOff x="0" y="0"/>
+          <a:chExt cx="0" cy="0"/>
+        </a:xfrm>
+      </p:grpSpPr>
+      <p:sp>
+        <p:nvSpPr>
+          <p:cNvPr id="2" name="Slide Image Placeholder 1"/>
+          <p:cNvSpPr>
+            <a:spLocks noGrp="1"/>
+          </p:cNvSpPr>
+          <p:nvPr>
+            <p:ph type="sldImg" idx="2"/>
+          </p:nvPr>
+        </p:nvSpPr>
+        <p:spPr/>
+      </p:sp>
+      <p:sp>
+        <p:nvSpPr>
+          <p:cNvPr id="3" name="Notes Placeholder 2"/>
+          <p:cNvSpPr>
+            <a:spLocks noGrp="1"/>
+          </p:cNvSpPr>
+          <p:nvPr>
+            <p:ph type="body" idx="3" sz="quarter"/>
+          </p:nvPr>
+        </p:nvSpPr>
+        <p:spPr/>
+        <p:txBody>
+          <a:bodyPr/>
+          <a:lstStyle/>
+          <a:p>
+            <a:r>
+              <a:t>PRESENTER NOTES (Slide 12):</a:t>
+            </a:r>
+          </a:p>
+          <a:p>
+            <a:r>
               <a:t>"Thank you. The repo is public — the program, the audits, the fuzz suite, the app. And the phone is on the table: let's take a live borrow on mainnet."</a:t>
             </a:r>
           </a:p>
@@ -1438,22 +1529,37 @@
           </a:p>
           <a:p>
             <a:r>
-              <a:t>"The ecosystem case: ClockLend turns SKR from a holding into a working asset — staked for discounts, locked as collateral, priced by Pyth. And it gives every Seeker wallet a portable credit history — the missing primitive for the social graph Solana Mobile is building."</a:t>
-            </a:r>
-          </a:p>
-          <a:p>
-            <a:r>
-              <a:t>Key Ecosystem Takeaway:</a:t>
-            </a:r>
-          </a:p>
-          <a:p>
-            <a:r>
-              <a:t>- Seeker needs real utility dApps that can't exist on Apple/Google App Stores.</a:t>
-            </a:r>
-          </a:p>
-          <a:p>
-            <a:r>
-              <a:t>- ClockLend leverages Seed Vault, MWA, and NFC hardware features.</a:t>
+              <a:t>"Here is how ClockLend makes money and generates real value:</a:t>
+            </a:r>
+          </a:p>
+          <a:p>
+            <a:r>
+              <a:t>1. 3 Automated Inflows: 0.25%-0.50% origination fees, 15% interest take-rate on repayments, and 5% liquidation margins.</a:t>
+            </a:r>
+          </a:p>
+          <a:p>
+            <a:r>
+              <a:t>2. Value Distribution: 50% of origination fees flow directly to SKR stakers as USDC dividends. Desk owners keep 85% of interest and 100% of principal.</a:t>
+            </a:r>
+          </a:p>
+          <a:p>
+            <a:r>
+              <a:t>3. Deflationary Flywheel: The developer can withdraw profits or execute automated SKR buyback-and-burn via Jupiter DEX or direct atomic burns, permanently decreasing SKR circulating supply on Solscan."</a:t>
+            </a:r>
+          </a:p>
+          <a:p>
+            <a:r>
+              <a:t>Key Business Takeaway:</a:t>
+            </a:r>
+          </a:p>
+          <a:p>
+            <a:r>
+              <a:t>- Real cash-flow protocol with no unbacked token emissions.</a:t>
+            </a:r>
+          </a:p>
+          <a:p>
+            <a:r>
+              <a:t>- LPs get real yield, stakers get USDC dividends, and SKR supply decreases.</a:t>
             </a:r>
           </a:p>
         </p:txBody>
@@ -4912,7 +5018,7 @@
         <p:spPr>
           <a:xfrm>
             <a:off x="731520" y="457200"/>
-            <a:ext cx="2569464" cy="347472"/>
+            <a:ext cx="2066543" cy="347472"/>
           </a:xfrm>
           <a:prstGeom prst="roundRect">
             <a:avLst/>
@@ -4953,7 +5059,7 @@
               </a:defRPr>
             </a:pPr>
             <a:r>
-              <a:t>THE ASK &amp; COMMITMENTS</a:t>
+              <a:t>ECOSYSTEM IMPACT</a:t>
             </a:r>
           </a:p>
         </p:txBody>
@@ -4991,7 +5097,7 @@
                   <a:srgbClr val="F8FAFC"/>
                 </a:solidFill>
               </a:rPr>
-              <a:t>Two prizes. </a:t>
+              <a:t>A lending layer for the </a:t>
             </a:r>
             <a:r>
               <a:rPr>
@@ -4999,7 +5105,7 @@
                   <a:srgbClr val="14F195"/>
                 </a:solidFill>
               </a:rPr>
-              <a:t>One launch</a:t>
+              <a:t>Seeker social graph</a:t>
             </a:r>
             <a:r>
               <a:rPr>
@@ -5023,7 +5129,7 @@
               </a:defRPr>
             </a:pPr>
             <a:r>
-              <a:t>A clear, actionable plan to take ClockLend from hackathon winner to Seeker essential.</a:t>
+              <a:t>Creating structural demand for SKR while delivering the flagship consumer lending dApp.</a:t>
             </a:r>
           </a:p>
         </p:txBody>
@@ -5117,8 +5223,8 @@
         </p:nvSpPr>
         <p:spPr>
           <a:xfrm>
-            <a:off x="960120" y="1920240"/>
-            <a:ext cx="4754880" cy="4023360"/>
+            <a:off x="960120" y="1874519"/>
+            <a:ext cx="4754880" cy="4114800"/>
           </a:xfrm>
           <a:prstGeom prst="rect">
             <a:avLst/>
@@ -5132,21 +5238,21 @@
           <a:lstStyle/>
           <a:p>
             <a:pPr>
-              <a:defRPr sz="2200" b="1">
-                <a:solidFill>
-                  <a:srgbClr val="FFB020"/>
+              <a:defRPr sz="2000" b="1">
+                <a:solidFill>
+                  <a:srgbClr val="14F195"/>
                 </a:solidFill>
                 <a:latin typeface="Trebuchet MS"/>
               </a:defRPr>
             </a:pPr>
             <a:r>
-              <a:t>🎯 What We Are Asking For</a:t>
+              <a:t>💎 Value Created for the SKR Token</a:t>
             </a:r>
           </a:p>
           <a:p>
             <a:pPr>
               <a:spcBef>
-                <a:spcPts val="1000"/>
+                <a:spcPts val="1200"/>
               </a:spcBef>
             </a:pPr>
             <a:r>
@@ -5155,22 +5261,22 @@
                   <a:srgbClr val="F8FAFC"/>
                 </a:solidFill>
               </a:rPr>
-              <a:t>🏆 CLOCK IN Grand Prize
+              <a:t>✔ Structural Staking Sink
 </a:t>
             </a:r>
             <a:r>
-              <a:rPr sz="1100">
+              <a:rPr sz="1150">
                 <a:solidFill>
                   <a:srgbClr val="CBD5E1"/>
                 </a:solidFill>
               </a:rPr>
-              <a:t>Recognition as the premier consumer mobile DeFi application built for the Solana Seeker ecosystem.</a:t>
+              <a:t>Every merchant opening a lending desk and every borrower seeking discounted rates locks SKR in protocol escrow contracts.</a:t>
             </a:r>
           </a:p>
           <a:p>
             <a:pPr>
               <a:spcBef>
-                <a:spcPts val="1000"/>
+                <a:spcPts val="1200"/>
               </a:spcBef>
             </a:pPr>
             <a:r>
@@ -5179,22 +5285,22 @@
                   <a:srgbClr val="F8FAFC"/>
                 </a:solidFill>
               </a:rPr>
-              <a:t>🏆 The $10,000 SKR Integration Prize
+              <a:t>✔ Collateral Float Removal
 </a:t>
             </a:r>
             <a:r>
-              <a:rPr sz="1100">
+              <a:rPr sz="1150">
                 <a:solidFill>
                   <a:srgbClr val="CBD5E1"/>
                 </a:solidFill>
               </a:rPr>
-              <a:t>For delivering the most comprehensive, economically robust SKR staking and oracle integration in the hackathon.</a:t>
+              <a:t>SKR locked as micro-loan collateral takes circulating supply off the market during active borrowing periods.</a:t>
             </a:r>
           </a:p>
           <a:p>
             <a:pPr>
               <a:spcBef>
-                <a:spcPts val="1000"/>
+                <a:spcPts val="1200"/>
               </a:spcBef>
             </a:pPr>
             <a:r>
@@ -5203,16 +5309,40 @@
                   <a:srgbClr val="F8FAFC"/>
                 </a:solidFill>
               </a:rPr>
-              <a:t>🏆 Solana Mobile Co-Marketing
+              <a:t>✔ First Genuine DeFi Utility
 </a:t>
             </a:r>
             <a:r>
-              <a:rPr sz="1100">
+              <a:rPr sz="1150">
                 <a:solidFill>
                   <a:srgbClr val="CBD5E1"/>
                 </a:solidFill>
               </a:rPr>
-              <a:t>Support for featured placement on the Solana dApp Store home feed upon official device ship date.</a:t>
+              <a:t>Transforms SKR from a speculative meme or governance token into a productive financial asset with cash-flow utility.</a:t>
+            </a:r>
+          </a:p>
+          <a:p>
+            <a:pPr>
+              <a:spcBef>
+                <a:spcPts val="1200"/>
+              </a:spcBef>
+            </a:pPr>
+            <a:r>
+              <a:rPr b="1" sz="1300">
+                <a:solidFill>
+                  <a:srgbClr val="F8FAFC"/>
+                </a:solidFill>
+              </a:rPr>
+              <a:t>✔ Counter-Cyclical Durability
+</a:t>
+            </a:r>
+            <a:r>
+              <a:rPr sz="1150">
+                <a:solidFill>
+                  <a:srgbClr val="CBD5E1"/>
+                </a:solidFill>
+              </a:rPr>
+              <a:t>Micro-credit demand remains high regardless of crypto bull or bear cycles, sustaining continuous protocol volume.</a:t>
             </a:r>
           </a:p>
         </p:txBody>
@@ -5270,8 +5400,8 @@
         </p:nvSpPr>
         <p:spPr>
           <a:xfrm>
-            <a:off x="6476695" y="1920240"/>
-            <a:ext cx="4754880" cy="4023360"/>
+            <a:off x="6476695" y="1874519"/>
+            <a:ext cx="4754880" cy="4114800"/>
           </a:xfrm>
           <a:prstGeom prst="rect">
             <a:avLst/>
@@ -5285,111 +5415,111 @@
           <a:lstStyle/>
           <a:p>
             <a:pPr>
-              <a:defRPr sz="2200" b="1">
-                <a:solidFill>
-                  <a:srgbClr val="14F195"/>
+              <a:defRPr sz="2000" b="1">
+                <a:solidFill>
+                  <a:srgbClr val="00D4FF"/>
                 </a:solidFill>
                 <a:latin typeface="Trebuchet MS"/>
               </a:defRPr>
             </a:pPr>
             <a:r>
-              <a:t>🚀 What We Commit to Deliver</a:t>
+              <a:t>📱 Value Created for the Solana Seeker</a:t>
             </a:r>
           </a:p>
           <a:p>
             <a:pPr>
               <a:spcBef>
-                <a:spcPts val="800"/>
+                <a:spcPts val="1200"/>
               </a:spcBef>
             </a:pPr>
             <a:r>
-              <a:rPr b="1" sz="1250">
+              <a:rPr b="1" sz="1300">
                 <a:solidFill>
                   <a:srgbClr val="F8FAFC"/>
                 </a:solidFill>
               </a:rPr>
-              <a:t>⚡ Solana dApp Store Launch
+              <a:t>✔ Flagship Financial Primitive
 </a:t>
             </a:r>
             <a:r>
-              <a:rPr sz="1100">
+              <a:rPr sz="1150">
                 <a:solidFill>
                   <a:srgbClr val="CBD5E1"/>
                 </a:solidFill>
               </a:rPr>
-              <a:t>Official submission and release package for all 150,000+ Solana Seeker pre-order customers.</a:t>
+              <a:t>A consumer-grade, everyday mobile dApp proving the consumer power of the Solana Mobile Stack and Seed Vault.</a:t>
             </a:r>
           </a:p>
           <a:p>
             <a:pPr>
               <a:spcBef>
-                <a:spcPts val="800"/>
+                <a:spcPts val="1200"/>
               </a:spcBef>
             </a:pPr>
             <a:r>
-              <a:rPr b="1" sz="1250">
+              <a:rPr b="1" sz="1300">
                 <a:solidFill>
                   <a:srgbClr val="F8FAFC"/>
                 </a:solidFill>
               </a:rPr>
-              <a:t>⚡ Mainnet Liquidity Seeding
+              <a:t>✔ Portable On-Chain Credit Identity
 </a:t>
             </a:r>
             <a:r>
-              <a:rPr sz="1100">
+              <a:rPr sz="1150">
                 <a:solidFill>
                   <a:srgbClr val="CBD5E1"/>
                 </a:solidFill>
               </a:rPr>
-              <a:t>Deploy dedicated capital to seed initial community lending desks for low-fee micro-borrowing.</a:t>
+              <a:t>Creates the first decentralized credit score that follows Seeker wallet holders across future Web3 applications.</a:t>
             </a:r>
           </a:p>
           <a:p>
             <a:pPr>
               <a:spcBef>
-                <a:spcPts val="800"/>
+                <a:spcPts val="1200"/>
               </a:spcBef>
             </a:pPr>
             <a:r>
-              <a:rPr b="1" sz="1250">
+              <a:rPr b="1" sz="1300">
                 <a:solidFill>
                   <a:srgbClr val="F8FAFC"/>
                 </a:solidFill>
               </a:rPr>
-              <a:t>⚡ First 1,000 Verified Borrowers
+              <a:t>✔ Organic Grassroots Distribution
 </a:t>
             </a:r>
             <a:r>
-              <a:rPr sz="1100">
+              <a:rPr sz="1150">
                 <a:solidFill>
                   <a:srgbClr val="CBD5E1"/>
                 </a:solidFill>
               </a:rPr>
-              <a:t>Targeted user onboarding campaign starting with verified Seeker Genesis Token holders.</a:t>
+              <a:t>NFC circle lending and community desks encourage peer-to-peer Seeker hardware recommendations.</a:t>
             </a:r>
           </a:p>
           <a:p>
             <a:pPr>
               <a:spcBef>
-                <a:spcPts val="800"/>
+                <a:spcPts val="1200"/>
               </a:spcBef>
             </a:pPr>
             <a:r>
-              <a:rPr b="1" sz="1250">
+              <a:rPr b="1" sz="1300">
                 <a:solidFill>
                   <a:srgbClr val="F8FAFC"/>
                 </a:solidFill>
               </a:rPr>
-              <a:t>⚡ TARDIS Social Feed Integration
+              <a:t>✔ TARDIS Social Synergy
 </a:t>
             </a:r>
             <a:r>
-              <a:rPr sz="1100">
+              <a:rPr sz="1150">
                 <a:solidFill>
                   <a:srgbClr val="CBD5E1"/>
                 </a:solidFill>
               </a:rPr>
-              <a:t>Enable native social micro-loans and peer debt gifting directly inside Seeker social feeds.</a:t>
+              <a:t>Seamless integration into Seeker social feeds for viral peer loans, debt gifts, and social circle rescue alerts.</a:t>
             </a:r>
           </a:p>
         </p:txBody>
@@ -5455,6 +5585,558 @@
           </a:p>
         </p:txBody>
       </p:sp>
+      <p:sp>
+        <p:nvSpPr>
+          <p:cNvPr id="3" name="Rounded Rectangle 2"/>
+          <p:cNvSpPr/>
+          <p:nvPr/>
+        </p:nvSpPr>
+        <p:spPr>
+          <a:xfrm>
+            <a:off x="731520" y="457200"/>
+            <a:ext cx="2569464" cy="347472"/>
+          </a:xfrm>
+          <a:prstGeom prst="roundRect">
+            <a:avLst/>
+          </a:prstGeom>
+          <a:solidFill>
+            <a:srgbClr val="102D3C"/>
+          </a:solidFill>
+          <a:ln w="12700">
+            <a:solidFill>
+              <a:srgbClr val="14F195"/>
+            </a:solidFill>
+          </a:ln>
+        </p:spPr>
+        <p:style>
+          <a:lnRef idx="1">
+            <a:schemeClr val="accent1"/>
+          </a:lnRef>
+          <a:fillRef idx="3">
+            <a:schemeClr val="accent1"/>
+          </a:fillRef>
+          <a:effectRef idx="2">
+            <a:schemeClr val="accent1"/>
+          </a:effectRef>
+          <a:fontRef idx="minor">
+            <a:schemeClr val="lt1"/>
+          </a:fontRef>
+        </p:style>
+        <p:txBody>
+          <a:bodyPr rtlCol="0" anchor="ctr" wrap="none"/>
+          <a:lstStyle/>
+          <a:p>
+            <a:pPr algn="ctr">
+              <a:defRPr sz="1000" b="1">
+                <a:solidFill>
+                  <a:srgbClr val="14F195"/>
+                </a:solidFill>
+                <a:latin typeface="Trebuchet MS"/>
+              </a:defRPr>
+            </a:pPr>
+            <a:r>
+              <a:t>THE ASK &amp; COMMITMENTS</a:t>
+            </a:r>
+          </a:p>
+        </p:txBody>
+      </p:sp>
+      <p:sp>
+        <p:nvSpPr>
+          <p:cNvPr id="4" name="TextBox 3"/>
+          <p:cNvSpPr txBox="1"/>
+          <p:nvPr/>
+        </p:nvSpPr>
+        <p:spPr>
+          <a:xfrm>
+            <a:off x="731520" y="868680"/>
+            <a:ext cx="10698480" cy="822960"/>
+          </a:xfrm>
+          <a:prstGeom prst="rect">
+            <a:avLst/>
+          </a:prstGeom>
+          <a:noFill/>
+        </p:spPr>
+        <p:txBody>
+          <a:bodyPr wrap="square" lIns="0" tIns="0" rIns="0" bIns="0">
+            <a:spAutoFit/>
+          </a:bodyPr>
+          <a:lstStyle/>
+          <a:p>
+            <a:pPr>
+              <a:defRPr sz="2800" b="1">
+                <a:latin typeface="Trebuchet MS"/>
+              </a:defRPr>
+            </a:pPr>
+            <a:r>
+              <a:rPr>
+                <a:solidFill>
+                  <a:srgbClr val="F8FAFC"/>
+                </a:solidFill>
+              </a:rPr>
+              <a:t>Two prizes. </a:t>
+            </a:r>
+            <a:r>
+              <a:rPr>
+                <a:solidFill>
+                  <a:srgbClr val="14F195"/>
+                </a:solidFill>
+              </a:rPr>
+              <a:t>One launch</a:t>
+            </a:r>
+            <a:r>
+              <a:rPr>
+                <a:solidFill>
+                  <a:srgbClr val="F8FAFC"/>
+                </a:solidFill>
+              </a:rPr>
+              <a:t>.</a:t>
+            </a:r>
+          </a:p>
+          <a:p>
+            <a:pPr>
+              <a:spcBef>
+                <a:spcPts val="400"/>
+              </a:spcBef>
+              <a:defRPr sz="1400">
+                <a:solidFill>
+                  <a:srgbClr val="94A3B8"/>
+                </a:solidFill>
+                <a:latin typeface="Arial"/>
+              </a:defRPr>
+            </a:pPr>
+            <a:r>
+              <a:t>A clear, actionable plan to take ClockLend from hackathon winner to Seeker essential.</a:t>
+            </a:r>
+          </a:p>
+        </p:txBody>
+      </p:sp>
+      <p:sp>
+        <p:nvSpPr>
+          <p:cNvPr id="5" name="TextBox 4"/>
+          <p:cNvSpPr txBox="1"/>
+          <p:nvPr/>
+        </p:nvSpPr>
+        <p:spPr>
+          <a:xfrm>
+            <a:off x="731520" y="6492240"/>
+            <a:ext cx="10698480" cy="274320"/>
+          </a:xfrm>
+          <a:prstGeom prst="rect">
+            <a:avLst/>
+          </a:prstGeom>
+          <a:noFill/>
+        </p:spPr>
+        <p:txBody>
+          <a:bodyPr wrap="none" lIns="0" tIns="0" rIns="0" bIns="0">
+            <a:spAutoFit/>
+          </a:bodyPr>
+          <a:lstStyle/>
+          <a:p>
+            <a:pPr>
+              <a:defRPr sz="950">
+                <a:solidFill>
+                  <a:srgbClr val="5A6E91"/>
+                </a:solidFill>
+                <a:latin typeface="Arial"/>
+              </a:defRPr>
+            </a:pPr>
+            <a:r>
+              <a:t>ClockLend · Solana Seeker Micro-Lending &amp; Social Pawns · CLOCK IN Hackathon 2026</a:t>
+            </a:r>
+          </a:p>
+        </p:txBody>
+      </p:sp>
+      <p:sp>
+        <p:nvSpPr>
+          <p:cNvPr id="6" name="Rounded Rectangle 5"/>
+          <p:cNvSpPr/>
+          <p:nvPr/>
+        </p:nvSpPr>
+        <p:spPr>
+          <a:xfrm>
+            <a:off x="731520" y="1691640"/>
+            <a:ext cx="5212080" cy="4480560"/>
+          </a:xfrm>
+          <a:prstGeom prst="roundRect">
+            <a:avLst/>
+          </a:prstGeom>
+          <a:solidFill>
+            <a:srgbClr val="182340"/>
+          </a:solidFill>
+          <a:ln w="12700">
+            <a:solidFill>
+              <a:srgbClr val="2D4169"/>
+            </a:solidFill>
+          </a:ln>
+        </p:spPr>
+        <p:style>
+          <a:lnRef idx="1">
+            <a:schemeClr val="accent1"/>
+          </a:lnRef>
+          <a:fillRef idx="3">
+            <a:schemeClr val="accent1"/>
+          </a:fillRef>
+          <a:effectRef idx="2">
+            <a:schemeClr val="accent1"/>
+          </a:effectRef>
+          <a:fontRef idx="minor">
+            <a:schemeClr val="lt1"/>
+          </a:fontRef>
+        </p:style>
+        <p:txBody>
+          <a:bodyPr rtlCol="0" anchor="ctr"/>
+          <a:lstStyle/>
+          <a:p>
+            <a:pPr algn="ctr"/>
+          </a:p>
+        </p:txBody>
+      </p:sp>
+      <p:sp>
+        <p:nvSpPr>
+          <p:cNvPr id="7" name="TextBox 6"/>
+          <p:cNvSpPr txBox="1"/>
+          <p:nvPr/>
+        </p:nvSpPr>
+        <p:spPr>
+          <a:xfrm>
+            <a:off x="960120" y="1920240"/>
+            <a:ext cx="4754880" cy="4023360"/>
+          </a:xfrm>
+          <a:prstGeom prst="rect">
+            <a:avLst/>
+          </a:prstGeom>
+          <a:noFill/>
+        </p:spPr>
+        <p:txBody>
+          <a:bodyPr wrap="square">
+            <a:spAutoFit/>
+          </a:bodyPr>
+          <a:lstStyle/>
+          <a:p>
+            <a:pPr>
+              <a:defRPr sz="2200" b="1">
+                <a:solidFill>
+                  <a:srgbClr val="FFB020"/>
+                </a:solidFill>
+                <a:latin typeface="Trebuchet MS"/>
+              </a:defRPr>
+            </a:pPr>
+            <a:r>
+              <a:t>🎯 What We Are Asking For</a:t>
+            </a:r>
+          </a:p>
+          <a:p>
+            <a:pPr>
+              <a:spcBef>
+                <a:spcPts val="1000"/>
+              </a:spcBef>
+            </a:pPr>
+            <a:r>
+              <a:rPr b="1" sz="1300">
+                <a:solidFill>
+                  <a:srgbClr val="F8FAFC"/>
+                </a:solidFill>
+              </a:rPr>
+              <a:t>🏆 CLOCK IN Grand Prize
+</a:t>
+            </a:r>
+            <a:r>
+              <a:rPr sz="1100">
+                <a:solidFill>
+                  <a:srgbClr val="CBD5E1"/>
+                </a:solidFill>
+              </a:rPr>
+              <a:t>Recognition as the premier consumer mobile DeFi application built for the Solana Seeker ecosystem.</a:t>
+            </a:r>
+          </a:p>
+          <a:p>
+            <a:pPr>
+              <a:spcBef>
+                <a:spcPts val="1000"/>
+              </a:spcBef>
+            </a:pPr>
+            <a:r>
+              <a:rPr b="1" sz="1300">
+                <a:solidFill>
+                  <a:srgbClr val="F8FAFC"/>
+                </a:solidFill>
+              </a:rPr>
+              <a:t>🏆 The $10,000 SKR Integration Prize
+</a:t>
+            </a:r>
+            <a:r>
+              <a:rPr sz="1100">
+                <a:solidFill>
+                  <a:srgbClr val="CBD5E1"/>
+                </a:solidFill>
+              </a:rPr>
+              <a:t>For delivering the most comprehensive, economically robust SKR staking and oracle integration in the hackathon.</a:t>
+            </a:r>
+          </a:p>
+          <a:p>
+            <a:pPr>
+              <a:spcBef>
+                <a:spcPts val="1000"/>
+              </a:spcBef>
+            </a:pPr>
+            <a:r>
+              <a:rPr b="1" sz="1300">
+                <a:solidFill>
+                  <a:srgbClr val="F8FAFC"/>
+                </a:solidFill>
+              </a:rPr>
+              <a:t>🏆 Solana Mobile Co-Marketing
+</a:t>
+            </a:r>
+            <a:r>
+              <a:rPr sz="1100">
+                <a:solidFill>
+                  <a:srgbClr val="CBD5E1"/>
+                </a:solidFill>
+              </a:rPr>
+              <a:t>Support for featured placement on the Solana dApp Store home feed upon official device ship date.</a:t>
+            </a:r>
+          </a:p>
+        </p:txBody>
+      </p:sp>
+      <p:sp>
+        <p:nvSpPr>
+          <p:cNvPr id="8" name="Rounded Rectangle 7"/>
+          <p:cNvSpPr/>
+          <p:nvPr/>
+        </p:nvSpPr>
+        <p:spPr>
+          <a:xfrm>
+            <a:off x="6248095" y="1691640"/>
+            <a:ext cx="5212080" cy="4480560"/>
+          </a:xfrm>
+          <a:prstGeom prst="roundRect">
+            <a:avLst/>
+          </a:prstGeom>
+          <a:solidFill>
+            <a:srgbClr val="182340"/>
+          </a:solidFill>
+          <a:ln w="19050">
+            <a:solidFill>
+              <a:srgbClr val="14F195"/>
+            </a:solidFill>
+          </a:ln>
+        </p:spPr>
+        <p:style>
+          <a:lnRef idx="1">
+            <a:schemeClr val="accent1"/>
+          </a:lnRef>
+          <a:fillRef idx="3">
+            <a:schemeClr val="accent1"/>
+          </a:fillRef>
+          <a:effectRef idx="2">
+            <a:schemeClr val="accent1"/>
+          </a:effectRef>
+          <a:fontRef idx="minor">
+            <a:schemeClr val="lt1"/>
+          </a:fontRef>
+        </p:style>
+        <p:txBody>
+          <a:bodyPr rtlCol="0" anchor="ctr"/>
+          <a:lstStyle/>
+          <a:p>
+            <a:pPr algn="ctr"/>
+          </a:p>
+        </p:txBody>
+      </p:sp>
+      <p:sp>
+        <p:nvSpPr>
+          <p:cNvPr id="9" name="TextBox 8"/>
+          <p:cNvSpPr txBox="1"/>
+          <p:nvPr/>
+        </p:nvSpPr>
+        <p:spPr>
+          <a:xfrm>
+            <a:off x="6476695" y="1920240"/>
+            <a:ext cx="4754880" cy="4023360"/>
+          </a:xfrm>
+          <a:prstGeom prst="rect">
+            <a:avLst/>
+          </a:prstGeom>
+          <a:noFill/>
+        </p:spPr>
+        <p:txBody>
+          <a:bodyPr wrap="square">
+            <a:spAutoFit/>
+          </a:bodyPr>
+          <a:lstStyle/>
+          <a:p>
+            <a:pPr>
+              <a:defRPr sz="2200" b="1">
+                <a:solidFill>
+                  <a:srgbClr val="14F195"/>
+                </a:solidFill>
+                <a:latin typeface="Trebuchet MS"/>
+              </a:defRPr>
+            </a:pPr>
+            <a:r>
+              <a:t>🚀 What We Commit to Deliver</a:t>
+            </a:r>
+          </a:p>
+          <a:p>
+            <a:pPr>
+              <a:spcBef>
+                <a:spcPts val="800"/>
+              </a:spcBef>
+            </a:pPr>
+            <a:r>
+              <a:rPr b="1" sz="1250">
+                <a:solidFill>
+                  <a:srgbClr val="F8FAFC"/>
+                </a:solidFill>
+              </a:rPr>
+              <a:t>⚡ Solana dApp Store Launch
+</a:t>
+            </a:r>
+            <a:r>
+              <a:rPr sz="1100">
+                <a:solidFill>
+                  <a:srgbClr val="CBD5E1"/>
+                </a:solidFill>
+              </a:rPr>
+              <a:t>Official submission and release package for all 150,000+ Solana Seeker pre-order customers.</a:t>
+            </a:r>
+          </a:p>
+          <a:p>
+            <a:pPr>
+              <a:spcBef>
+                <a:spcPts val="800"/>
+              </a:spcBef>
+            </a:pPr>
+            <a:r>
+              <a:rPr b="1" sz="1250">
+                <a:solidFill>
+                  <a:srgbClr val="F8FAFC"/>
+                </a:solidFill>
+              </a:rPr>
+              <a:t>⚡ Mainnet Liquidity Seeding
+</a:t>
+            </a:r>
+            <a:r>
+              <a:rPr sz="1100">
+                <a:solidFill>
+                  <a:srgbClr val="CBD5E1"/>
+                </a:solidFill>
+              </a:rPr>
+              <a:t>Deploy dedicated capital to seed initial community lending desks for low-fee micro-borrowing.</a:t>
+            </a:r>
+          </a:p>
+          <a:p>
+            <a:pPr>
+              <a:spcBef>
+                <a:spcPts val="800"/>
+              </a:spcBef>
+            </a:pPr>
+            <a:r>
+              <a:rPr b="1" sz="1250">
+                <a:solidFill>
+                  <a:srgbClr val="F8FAFC"/>
+                </a:solidFill>
+              </a:rPr>
+              <a:t>⚡ First 1,000 Verified Borrowers
+</a:t>
+            </a:r>
+            <a:r>
+              <a:rPr sz="1100">
+                <a:solidFill>
+                  <a:srgbClr val="CBD5E1"/>
+                </a:solidFill>
+              </a:rPr>
+              <a:t>Targeted user onboarding campaign starting with verified Seeker Genesis Token holders.</a:t>
+            </a:r>
+          </a:p>
+          <a:p>
+            <a:pPr>
+              <a:spcBef>
+                <a:spcPts val="800"/>
+              </a:spcBef>
+            </a:pPr>
+            <a:r>
+              <a:rPr b="1" sz="1250">
+                <a:solidFill>
+                  <a:srgbClr val="F8FAFC"/>
+                </a:solidFill>
+              </a:rPr>
+              <a:t>⚡ TARDIS Social Feed Integration
+</a:t>
+            </a:r>
+            <a:r>
+              <a:rPr sz="1100">
+                <a:solidFill>
+                  <a:srgbClr val="CBD5E1"/>
+                </a:solidFill>
+              </a:rPr>
+              <a:t>Enable native social micro-loans and peer debt gifting directly inside Seeker social feeds.</a:t>
+            </a:r>
+          </a:p>
+        </p:txBody>
+      </p:sp>
+    </p:spTree>
+  </p:cSld>
+  <p:clrMapOvr>
+    <a:masterClrMapping/>
+  </p:clrMapOvr>
+</p:sld>
+</file>
+
+<file path=ppt/slides/slide12.xml><?xml version="1.0" encoding="utf-8"?>
+<p:sld xmlns:a="http://schemas.openxmlformats.org/drawingml/2006/main" xmlns:p="http://schemas.openxmlformats.org/presentationml/2006/main" xmlns:r="http://schemas.openxmlformats.org/officeDocument/2006/relationships">
+  <p:cSld>
+    <p:spTree>
+      <p:nvGrpSpPr>
+        <p:cNvPr id="1" name=""/>
+        <p:cNvGrpSpPr/>
+        <p:nvPr/>
+      </p:nvGrpSpPr>
+      <p:grpSpPr/>
+      <p:sp>
+        <p:nvSpPr>
+          <p:cNvPr id="2" name="Rectangle 1"/>
+          <p:cNvSpPr/>
+          <p:nvPr/>
+        </p:nvSpPr>
+        <p:spPr>
+          <a:xfrm>
+            <a:off x="0" y="0"/>
+            <a:ext cx="12191695" cy="6858000"/>
+          </a:xfrm>
+          <a:prstGeom prst="rect">
+            <a:avLst/>
+          </a:prstGeom>
+          <a:solidFill>
+            <a:srgbClr val="0F1830"/>
+          </a:solidFill>
+          <a:ln>
+            <a:noFill/>
+          </a:ln>
+        </p:spPr>
+        <p:style>
+          <a:lnRef idx="1">
+            <a:schemeClr val="accent1"/>
+          </a:lnRef>
+          <a:fillRef idx="3">
+            <a:schemeClr val="accent1"/>
+          </a:fillRef>
+          <a:effectRef idx="2">
+            <a:schemeClr val="accent1"/>
+          </a:effectRef>
+          <a:fontRef idx="minor">
+            <a:schemeClr val="lt1"/>
+          </a:fontRef>
+        </p:style>
+        <p:txBody>
+          <a:bodyPr rtlCol="0" anchor="ctr"/>
+          <a:lstStyle/>
+          <a:p>
+            <a:pPr algn="ctr"/>
+          </a:p>
+        </p:txBody>
+      </p:sp>
       <p:pic>
         <p:nvPicPr>
           <p:cNvPr id="3" name="Picture 2" descr="logo.png"/>
@@ -11333,7 +12015,7 @@
         <p:spPr>
           <a:xfrm>
             <a:off x="731520" y="457200"/>
-            <a:ext cx="2066543" cy="347472"/>
+            <a:ext cx="3474720" cy="347472"/>
           </a:xfrm>
           <a:prstGeom prst="roundRect">
             <a:avLst/>
@@ -11374,7 +12056,7 @@
               </a:defRPr>
             </a:pPr>
             <a:r>
-              <a:t>ECOSYSTEM IMPACT</a:t>
+              <a:t>REVENUE MODEL &amp; TOKEN FLYWHEEL</a:t>
             </a:r>
           </a:p>
         </p:txBody>
@@ -11412,7 +12094,7 @@
                   <a:srgbClr val="F8FAFC"/>
                 </a:solidFill>
               </a:rPr>
-              <a:t>A lending layer for the </a:t>
+              <a:t>Protocol monetization driving </a:t>
             </a:r>
             <a:r>
               <a:rPr>
@@ -11420,7 +12102,7 @@
                   <a:srgbClr val="14F195"/>
                 </a:solidFill>
               </a:rPr>
-              <a:t>Seeker social graph</a:t>
+              <a:t>staker yields &amp; token burns.</a:t>
             </a:r>
             <a:r>
               <a:rPr>
@@ -11428,7 +12110,7 @@
                   <a:srgbClr val="F8FAFC"/>
                 </a:solidFill>
               </a:rPr>
-              <a:t>.</a:t>
+              <a:t/>
             </a:r>
           </a:p>
           <a:p>
@@ -11444,7 +12126,7 @@
               </a:defRPr>
             </a:pPr>
             <a:r>
-              <a:t>Creating structural demand for SKR while delivering the flagship consumer lending dApp.</a:t>
+              <a:t>Automated on-chain fee distribution paired with developer-driven spot buybacks.</a:t>
             </a:r>
           </a:p>
         </p:txBody>
@@ -11494,7 +12176,7 @@
         <p:spPr>
           <a:xfrm>
             <a:off x="731520" y="1691640"/>
-            <a:ext cx="5212080" cy="4480560"/>
+            <a:ext cx="3413455" cy="4526280"/>
           </a:xfrm>
           <a:prstGeom prst="roundRect">
             <a:avLst/>
@@ -11538,8 +12220,8 @@
         </p:nvSpPr>
         <p:spPr>
           <a:xfrm>
-            <a:off x="960120" y="1874519"/>
-            <a:ext cx="4754880" cy="4114800"/>
+            <a:off x="914400" y="1874519"/>
+            <a:ext cx="3047695" cy="4160520"/>
           </a:xfrm>
           <a:prstGeom prst="rect">
             <a:avLst/>
@@ -11553,111 +12235,90 @@
           <a:lstStyle/>
           <a:p>
             <a:pPr>
-              <a:defRPr sz="2000" b="1">
-                <a:solidFill>
-                  <a:srgbClr val="14F195"/>
+              <a:defRPr sz="1800" b="1">
+                <a:solidFill>
+                  <a:srgbClr val="FFB020"/>
                 </a:solidFill>
                 <a:latin typeface="Trebuchet MS"/>
               </a:defRPr>
             </a:pPr>
             <a:r>
-              <a:t>💎 Value Created for the SKR Token</a:t>
+              <a:t>💰 3 Protocol Inflows</a:t>
             </a:r>
           </a:p>
           <a:p>
             <a:pPr>
               <a:spcBef>
-                <a:spcPts val="1200"/>
+                <a:spcPts val="200"/>
               </a:spcBef>
-            </a:pPr>
-            <a:r>
-              <a:rPr b="1" sz="1300">
+              <a:defRPr sz="1100" b="1">
                 <a:solidFill>
                   <a:srgbClr val="F8FAFC"/>
                 </a:solidFill>
-              </a:rPr>
-              <a:t>✔ Structural Staking Sink
-</a:t>
-            </a:r>
+              </a:defRPr>
+            </a:pPr>
+            <a:r>
+              <a:t>Automated Monetization</a:t>
+            </a:r>
+          </a:p>
+          <a:p>
+            <a:pPr>
+              <a:spcBef>
+                <a:spcPts val="1000"/>
+              </a:spcBef>
+            </a:pPr>
             <a:r>
               <a:rPr sz="1150">
                 <a:solidFill>
                   <a:srgbClr val="CBD5E1"/>
                 </a:solidFill>
               </a:rPr>
-              <a:t>Every merchant opening a lending desk and every borrower seeking discounted rates locks SKR in protocol escrow contracts.</a:t>
+              <a:t>• Loan Origination Fees: 0.25% on SOL, 0.50% on USDC/SKR withheld upfront at disbursement.</a:t>
             </a:r>
           </a:p>
           <a:p>
             <a:pPr>
               <a:spcBef>
-                <a:spcPts val="1200"/>
+                <a:spcPts val="1000"/>
               </a:spcBef>
             </a:pPr>
             <a:r>
-              <a:rPr b="1" sz="1300">
-                <a:solidFill>
-                  <a:srgbClr val="F8FAFC"/>
-                </a:solidFill>
-              </a:rPr>
-              <a:t>✔ Collateral Float Removal
-</a:t>
-            </a:r>
-            <a:r>
               <a:rPr sz="1150">
                 <a:solidFill>
                   <a:srgbClr val="CBD5E1"/>
                 </a:solidFill>
               </a:rPr>
-              <a:t>SKR locked as micro-loan collateral takes circulating supply off the market during active borrowing periods.</a:t>
+              <a:t>• 15% Interest Take-Rate: Diverted automatically from borrower repayments to Treasury PDA.</a:t>
             </a:r>
           </a:p>
           <a:p>
             <a:pPr>
               <a:spcBef>
-                <a:spcPts val="1200"/>
+                <a:spcPts val="1000"/>
               </a:spcBef>
             </a:pPr>
             <a:r>
-              <a:rPr b="1" sz="1300">
-                <a:solidFill>
-                  <a:srgbClr val="F8FAFC"/>
-                </a:solidFill>
-              </a:rPr>
-              <a:t>✔ First Genuine DeFi Utility
-</a:t>
-            </a:r>
-            <a:r>
               <a:rPr sz="1150">
                 <a:solidFill>
                   <a:srgbClr val="CBD5E1"/>
                 </a:solidFill>
               </a:rPr>
-              <a:t>Transforms SKR from a speculative meme or governance token into a productive financial asset with cash-flow utility.</a:t>
+              <a:t>• 5% Liquidation Margin: Captured on seized collateral when defaults exceed 24h grace.</a:t>
             </a:r>
           </a:p>
           <a:p>
             <a:pPr>
               <a:spcBef>
-                <a:spcPts val="1200"/>
+                <a:spcPts val="1000"/>
               </a:spcBef>
             </a:pPr>
             <a:r>
-              <a:rPr b="1" sz="1300">
-                <a:solidFill>
-                  <a:srgbClr val="F8FAFC"/>
-                </a:solidFill>
-              </a:rPr>
-              <a:t>✔ Counter-Cyclical Durability
-</a:t>
-            </a:r>
-            <a:r>
               <a:rPr sz="1150">
                 <a:solidFill>
                   <a:srgbClr val="CBD5E1"/>
                 </a:solidFill>
               </a:rPr>
-              <a:t>Micro-credit demand remains high regardless of crypto bull or bear cycles, sustaining continuous protocol volume.</a:t>
+              <a:t>• Zero Float / Macro-Free: Enforced deterministically in native SBF Rust contract.</a:t>
             </a:r>
           </a:p>
         </p:txBody>
@@ -11670,8 +12331,164 @@
         </p:nvSpPr>
         <p:spPr>
           <a:xfrm>
-            <a:off x="6248095" y="1691640"/>
-            <a:ext cx="5212080" cy="4480560"/>
+            <a:off x="4389120" y="1691640"/>
+            <a:ext cx="3413455" cy="4526280"/>
+          </a:xfrm>
+          <a:prstGeom prst="roundRect">
+            <a:avLst/>
+          </a:prstGeom>
+          <a:solidFill>
+            <a:srgbClr val="182340"/>
+          </a:solidFill>
+          <a:ln w="12700">
+            <a:solidFill>
+              <a:srgbClr val="2D4169"/>
+            </a:solidFill>
+          </a:ln>
+        </p:spPr>
+        <p:style>
+          <a:lnRef idx="1">
+            <a:schemeClr val="accent1"/>
+          </a:lnRef>
+          <a:fillRef idx="3">
+            <a:schemeClr val="accent1"/>
+          </a:fillRef>
+          <a:effectRef idx="2">
+            <a:schemeClr val="accent1"/>
+          </a:effectRef>
+          <a:fontRef idx="minor">
+            <a:schemeClr val="lt1"/>
+          </a:fontRef>
+        </p:style>
+        <p:txBody>
+          <a:bodyPr rtlCol="0" anchor="ctr"/>
+          <a:lstStyle/>
+          <a:p>
+            <a:pPr algn="ctr"/>
+          </a:p>
+        </p:txBody>
+      </p:sp>
+      <p:sp>
+        <p:nvSpPr>
+          <p:cNvPr id="9" name="TextBox 8"/>
+          <p:cNvSpPr txBox="1"/>
+          <p:nvPr/>
+        </p:nvSpPr>
+        <p:spPr>
+          <a:xfrm>
+            <a:off x="4572000" y="1874519"/>
+            <a:ext cx="3047695" cy="4160520"/>
+          </a:xfrm>
+          <a:prstGeom prst="rect">
+            <a:avLst/>
+          </a:prstGeom>
+          <a:noFill/>
+        </p:spPr>
+        <p:txBody>
+          <a:bodyPr wrap="square">
+            <a:spAutoFit/>
+          </a:bodyPr>
+          <a:lstStyle/>
+          <a:p>
+            <a:pPr>
+              <a:defRPr sz="1800" b="1">
+                <a:solidFill>
+                  <a:srgbClr val="14F195"/>
+                </a:solidFill>
+                <a:latin typeface="Trebuchet MS"/>
+              </a:defRPr>
+            </a:pPr>
+            <a:r>
+              <a:t>⚖️ On-Chain Fee Routing</a:t>
+            </a:r>
+          </a:p>
+          <a:p>
+            <a:pPr>
+              <a:spcBef>
+                <a:spcPts val="200"/>
+              </a:spcBef>
+              <a:defRPr sz="1100" b="1">
+                <a:solidFill>
+                  <a:srgbClr val="F8FAFC"/>
+                </a:solidFill>
+              </a:defRPr>
+            </a:pPr>
+            <a:r>
+              <a:t>Decentralized Value Split</a:t>
+            </a:r>
+          </a:p>
+          <a:p>
+            <a:pPr>
+              <a:spcBef>
+                <a:spcPts val="1000"/>
+              </a:spcBef>
+            </a:pPr>
+            <a:r>
+              <a:rPr sz="1150">
+                <a:solidFill>
+                  <a:srgbClr val="CBD5E1"/>
+                </a:solidFill>
+              </a:rPr>
+              <a:t>• 50% of Origination Fees: Direct USDC dividend yield to SKR stakers via SkrYieldVault PDA.</a:t>
+            </a:r>
+          </a:p>
+          <a:p>
+            <a:pPr>
+              <a:spcBef>
+                <a:spcPts val="1000"/>
+              </a:spcBef>
+            </a:pPr>
+            <a:r>
+              <a:rPr sz="1150">
+                <a:solidFill>
+                  <a:srgbClr val="CBD5E1"/>
+                </a:solidFill>
+              </a:rPr>
+              <a:t>• 85% of Loan Interest: Paid directly into Desk Owner Vaults (100% principal protected).</a:t>
+            </a:r>
+          </a:p>
+          <a:p>
+            <a:pPr>
+              <a:spcBef>
+                <a:spcPts val="1000"/>
+              </a:spcBef>
+            </a:pPr>
+            <a:r>
+              <a:rPr sz="1150">
+                <a:solidFill>
+                  <a:srgbClr val="CBD5E1"/>
+                </a:solidFill>
+              </a:rPr>
+              <a:t>• 100% of P2P Loan Interest: Directly transferred to peer funder wallets.</a:t>
+            </a:r>
+          </a:p>
+          <a:p>
+            <a:pPr>
+              <a:spcBef>
+                <a:spcPts val="1000"/>
+              </a:spcBef>
+            </a:pPr>
+            <a:r>
+              <a:rPr sz="1150">
+                <a:solidFill>
+                  <a:srgbClr val="CBD5E1"/>
+                </a:solidFill>
+              </a:rPr>
+              <a:t>• Treasury PDA Reserve: Collects remaining fees and margins for growth and token burns.</a:t>
+            </a:r>
+          </a:p>
+        </p:txBody>
+      </p:sp>
+      <p:sp>
+        <p:nvSpPr>
+          <p:cNvPr id="10" name="Rounded Rectangle 9"/>
+          <p:cNvSpPr/>
+          <p:nvPr/>
+        </p:nvSpPr>
+        <p:spPr>
+          <a:xfrm>
+            <a:off x="8046720" y="1691640"/>
+            <a:ext cx="3413455" cy="4526280"/>
           </a:xfrm>
           <a:prstGeom prst="roundRect">
             <a:avLst/>
@@ -11709,14 +12526,14 @@
       </p:sp>
       <p:sp>
         <p:nvSpPr>
-          <p:cNvPr id="9" name="TextBox 8"/>
+          <p:cNvPr id="11" name="TextBox 10"/>
           <p:cNvSpPr txBox="1"/>
           <p:nvPr/>
         </p:nvSpPr>
         <p:spPr>
           <a:xfrm>
-            <a:off x="6476695" y="1874519"/>
-            <a:ext cx="4754880" cy="4114800"/>
+            <a:off x="8229600" y="1874519"/>
+            <a:ext cx="3047695" cy="4160520"/>
           </a:xfrm>
           <a:prstGeom prst="rect">
             <a:avLst/>
@@ -11730,7 +12547,7 @@
           <a:lstStyle/>
           <a:p>
             <a:pPr>
-              <a:defRPr sz="2000" b="1">
+              <a:defRPr sz="1800" b="1">
                 <a:solidFill>
                   <a:srgbClr val="00D4FF"/>
                 </a:solidFill>
@@ -11738,103 +12555,82 @@
               </a:defRPr>
             </a:pPr>
             <a:r>
-              <a:t>📱 Value Created for the Solana Seeker</a:t>
+              <a:t>🔥 SKR Buyback &amp; Burn</a:t>
             </a:r>
           </a:p>
           <a:p>
             <a:pPr>
               <a:spcBef>
-                <a:spcPts val="1200"/>
+                <a:spcPts val="200"/>
               </a:spcBef>
-            </a:pPr>
-            <a:r>
-              <a:rPr b="1" sz="1300">
+              <a:defRPr sz="1100" b="1">
                 <a:solidFill>
                   <a:srgbClr val="F8FAFC"/>
                 </a:solidFill>
-              </a:rPr>
-              <a:t>✔ Flagship Financial Primitive
-</a:t>
-            </a:r>
+              </a:defRPr>
+            </a:pPr>
+            <a:r>
+              <a:t>Deflationary Token Flywheel</a:t>
+            </a:r>
+          </a:p>
+          <a:p>
+            <a:pPr>
+              <a:spcBef>
+                <a:spcPts val="1000"/>
+              </a:spcBef>
+            </a:pPr>
             <a:r>
               <a:rPr sz="1150">
                 <a:solidFill>
                   <a:srgbClr val="CBD5E1"/>
                 </a:solidFill>
               </a:rPr>
-              <a:t>A consumer-grade, everyday mobile dApp proving the consumer power of the Solana Mobile Stack and Seed Vault.</a:t>
+              <a:t>• Direct Burn: Instant atomic SPL burn for Treasury SKR (zero DEX fees, zero slippage).</a:t>
             </a:r>
           </a:p>
           <a:p>
             <a:pPr>
               <a:spcBef>
-                <a:spcPts val="1200"/>
+                <a:spcPts val="1000"/>
               </a:spcBef>
             </a:pPr>
             <a:r>
-              <a:rPr b="1" sz="1300">
-                <a:solidFill>
-                  <a:srgbClr val="F8FAFC"/>
-                </a:solidFill>
-              </a:rPr>
-              <a:t>✔ Portable On-Chain Credit Identity
-</a:t>
-            </a:r>
-            <a:r>
               <a:rPr sz="1150">
                 <a:solidFill>
                   <a:srgbClr val="CBD5E1"/>
                 </a:solidFill>
               </a:rPr>
-              <a:t>Creates the first decentralized credit score that follows Seeker wallet holders across future Web3 applications.</a:t>
+              <a:t>• Jupiter Spot Buy &amp; Burn: Treasury USDC/SOL executes open-market buy orders and burns SKR.</a:t>
             </a:r>
           </a:p>
           <a:p>
             <a:pPr>
               <a:spcBef>
-                <a:spcPts val="1200"/>
+                <a:spcPts val="1000"/>
               </a:spcBef>
             </a:pPr>
             <a:r>
-              <a:rPr b="1" sz="1300">
-                <a:solidFill>
-                  <a:srgbClr val="F8FAFC"/>
-                </a:solidFill>
-              </a:rPr>
-              <a:t>✔ Organic Grassroots Distribution
-</a:t>
-            </a:r>
-            <a:r>
               <a:rPr sz="1150">
                 <a:solidFill>
                   <a:srgbClr val="CBD5E1"/>
                 </a:solidFill>
               </a:rPr>
-              <a:t>NFC circle lending and community desks encourage peer-to-peer Seeker hardware recommendations.</a:t>
+              <a:t>• Dynamic Developer Control: Developer chooses exact amount or % based on market conditions.</a:t>
             </a:r>
           </a:p>
           <a:p>
             <a:pPr>
               <a:spcBef>
-                <a:spcPts val="1200"/>
+                <a:spcPts val="1000"/>
               </a:spcBef>
             </a:pPr>
             <a:r>
-              <a:rPr b="1" sz="1300">
-                <a:solidFill>
-                  <a:srgbClr val="F8FAFC"/>
-                </a:solidFill>
-              </a:rPr>
-              <a:t>✔ TARDIS Social Synergy
-</a:t>
-            </a:r>
-            <a:r>
               <a:rPr sz="1150">
                 <a:solidFill>
                   <a:srgbClr val="CBD5E1"/>
                 </a:solidFill>
               </a:rPr>
-              <a:t>Seamless integration into Seeker social feeds for viral peer loans, debt gifts, and social circle rescue alerts.</a:t>
+              <a:t>• Verifiable On-Chain Proof: Public Solscan transaction proof for every burn event.</a:t>
             </a:r>
           </a:p>
         </p:txBody>

</xml_diff>

<commit_message>
docs: formalize 30% protocol revenue commitment for SKR buyback & burn across all documentation and slide decks
</commit_message>
<xml_diff>
--- a/docs/ClockLend_Pitch_Deck.pptx
+++ b/docs/ClockLend_Pitch_Deck.pptx
@@ -1544,7 +1544,7 @@
           </a:p>
           <a:p>
             <a:r>
-              <a:t>3. Deflationary Flywheel: The developer can withdraw profits or execute automated SKR buyback-and-burn via Jupiter DEX or direct atomic burns, permanently decreasing SKR circulating supply on Solscan."</a:t>
+              <a:t>3. 30% Deflationary Commitment: 30% of all project revenue is used to buy and burn SKR tokens via Jupiter DEX and direct on-chain burns, permanently shrinking circulating supply and rewarding long-term holders."</a:t>
             </a:r>
           </a:p>
           <a:p>
@@ -12094,7 +12094,7 @@
                   <a:srgbClr val="F8FAFC"/>
                 </a:solidFill>
               </a:rPr>
-              <a:t>Protocol monetization driving </a:t>
+              <a:t>Protocol monetization driving staker yields &amp; </a:t>
             </a:r>
             <a:r>
               <a:rPr>
@@ -12102,7 +12102,7 @@
                   <a:srgbClr val="14F195"/>
                 </a:solidFill>
               </a:rPr>
-              <a:t>staker yields &amp; token burns.</a:t>
+              <a:t>30% token burns.</a:t>
             </a:r>
             <a:r>
               <a:rPr>
@@ -12126,7 +12126,7 @@
               </a:defRPr>
             </a:pPr>
             <a:r>
-              <a:t>Automated on-chain fee distribution paired with developer-driven spot buybacks.</a:t>
+              <a:t>Automated on-chain fee distribution paired with 30% revenue buyback &amp; burn.</a:t>
             </a:r>
           </a:p>
         </p:txBody>
@@ -12474,7 +12474,7 @@
                   <a:srgbClr val="CBD5E1"/>
                 </a:solidFill>
               </a:rPr>
-              <a:t>• Treasury PDA Reserve: Collects remaining fees and margins for growth and token burns.</a:t>
+              <a:t>• Treasury PDA Reserve: 70% reserved for protocol operations, insurance, and growth.</a:t>
             </a:r>
           </a:p>
         </p:txBody>
@@ -12555,7 +12555,7 @@
               </a:defRPr>
             </a:pPr>
             <a:r>
-              <a:t>🔥 SKR Buyback &amp; Burn</a:t>
+              <a:t>🔥 30% Revenue Buy &amp; Burn</a:t>
             </a:r>
           </a:p>
           <a:p>
@@ -12585,7 +12585,7 @@
                   <a:srgbClr val="CBD5E1"/>
                 </a:solidFill>
               </a:rPr>
-              <a:t>• Direct Burn: Instant atomic SPL burn for Treasury SKR (zero DEX fees, zero slippage).</a:t>
+              <a:t>• 30% Revenue Commitment: 30% of all project revenue is dedicated to buying &amp; burning SKR.</a:t>
             </a:r>
           </a:p>
           <a:p>
@@ -12600,7 +12600,7 @@
                   <a:srgbClr val="CBD5E1"/>
                 </a:solidFill>
               </a:rPr>
-              <a:t>• Jupiter Spot Buy &amp; Burn: Treasury USDC/SOL executes open-market buy orders and burns SKR.</a:t>
+              <a:t>• Jupiter Spot Buy &amp; Burn: Treasury USDC/SOL executes market buy orders on DEX, elevating price floor.</a:t>
             </a:r>
           </a:p>
           <a:p>
@@ -12615,7 +12615,7 @@
                   <a:srgbClr val="CBD5E1"/>
                 </a:solidFill>
               </a:rPr>
-              <a:t>• Dynamic Developer Control: Developer chooses exact amount or % based on market conditions.</a:t>
+              <a:t>• Direct SPL Burn: Atomically burns Treasury-accumulated SKR with zero slippage and zero fees.</a:t>
             </a:r>
           </a:p>
           <a:p>
@@ -12630,7 +12630,7 @@
                   <a:srgbClr val="CBD5E1"/>
                 </a:solidFill>
               </a:rPr>
-              <a:t>• Verifiable On-Chain Proof: Public Solscan transaction proof for every burn event.</a:t>
+              <a:t>• Verifiable On-Chain Proof: Permanent supply destruction verified with public Solscan proofs.</a:t>
             </a:r>
           </a:p>
         </p:txBody>

</xml_diff>